<commit_message>
feat(analysis): Implement longitudinal SVI model & 2030 forecast
- Added Master Profile dataset (2010-2024) with robust error handling
- Implemented Social Vulnerability Index (SVI) ranking logic
- Added K-Means Clustering to identify 'Risk Profiles'
- Developed 'Evacuation Crisis' and 'Blight/Abandonment' indices
- Implemented Linear Regression model for 2030 SVI forecasting
- Generated final Executive Synthesis for dashboard integration
</commit_message>
<xml_diff>
--- a/project_reports/Capstone_Proposal_RiveraruizJose_7FEB2026.pptx
+++ b/project_reports/Capstone_Proposal_RiveraruizJose_7FEB2026.pptx
@@ -19410,7 +19410,7 @@
           <p:nvPr>
             <p:extLst>
               <p:ext uri="{D42A27DB-BD31-4B8C-83A1-F6EECF244321}">
-                <p14:modId xmlns:p14="http://schemas.microsoft.com/office/powerpoint/2010/main" val="1899420010"/>
+                <p14:modId xmlns:p14="http://schemas.microsoft.com/office/powerpoint/2010/main" val="683318561"/>
               </p:ext>
             </p:extLst>
           </p:nvPr>
@@ -20356,7 +20356,7 @@
                           <a:effectLst/>
                           <a:latin typeface="Merriweather" pitchFamily="2" charset="77"/>
                         </a:rPr>
-                        <a:t>• Poverty Rate</a:t>
+                        <a:t>• Poverty Rate, Single parent</a:t>
                       </a:r>
                     </a:p>
                     <a:p>
@@ -20440,7 +20440,7 @@
                           <a:ea typeface="+mn-ea"/>
                           <a:cs typeface="+mn-cs"/>
                         </a:rPr>
-                        <a:t>16 census-based variables</a:t>
+                        <a:t>15 census-based variables</a:t>
                       </a:r>
                     </a:p>
                   </a:txBody>

</xml_diff>